<commit_message>
Finalize ground-truth runs and reporting
</commit_message>
<xml_diff>
--- a/docs/reports/2026-03-31_hmarl_project_update_google_slides_import.pptx
+++ b/docs/reports/2026-03-31_hmarl_project_update_google_slides_import.pptx
@@ -3260,7 +3260,7 @@
                 </a:solidFill>
                 <a:latin typeface="Aptos"/>
               </a:rPr>
-              <a:t>Project update: simulator background, reward redesign, controlled validation benchmark, current progress, and next steps.</a:t>
+              <a:t>Project update: simulator background, reward redesign, continuous + ground_truth final run path, current progress, and next steps.</a:t>
             </a:r>
           </a:p>
         </p:txBody>
@@ -3338,7 +3338,7 @@
                 </a:solidFill>
                 <a:latin typeface="Aptos"/>
               </a:rPr>
-              <a:t>We now have both a strong continuous baseline and a controlled benchmark for validating the core control logic before reintroducing forecast uncertainty.</a:t>
+              <a:t>We now have a clean final path for the project: continuous scheduling, reliable forecasts, strong diagnostics, and a reproducible local run plan.</a:t>
             </a:r>
           </a:p>
         </p:txBody>
@@ -3514,8 +3514,8 @@
                 </a:solidFill>
                 <a:latin typeface="Aptos"/>
               </a:rPr>
-              <a:t>Baseline:
-v3 + GT benchmark</a:t>
+              <a:t>Final path:
+continuous + GT</a:t>
             </a:r>
           </a:p>
         </p:txBody>
@@ -3780,7 +3780,7 @@
                 </a:solidFill>
                 <a:latin typeface="Aptos Display"/>
               </a:rPr>
-              <a:t>v3 + GT</a:t>
+              <a:t>Cont. + GT</a:t>
             </a:r>
           </a:p>
         </p:txBody>
@@ -3815,7 +3815,7 @@
                 </a:solidFill>
                 <a:latin typeface="Aptos"/>
               </a:rPr>
-              <a:t>Operating baseline plus validation benchmark</a:t>
+              <a:t>Continuous environment with reliable forecasts</a:t>
             </a:r>
           </a:p>
         </p:txBody>
@@ -4682,7 +4682,7 @@
                 </a:solidFill>
                 <a:latin typeface="Aptos Display"/>
               </a:rPr>
-              <a:t>Validation variants</a:t>
+              <a:t>Final run cleanup</a:t>
             </a:r>
           </a:p>
         </p:txBody>
@@ -4717,7 +4717,7 @@
                 </a:solidFill>
                 <a:latin typeface="Aptos"/>
               </a:rPr>
-              <a:t>Added single_mission and ground_truth as controlled debugging modes.</a:t>
+              <a:t>Moved the finish line to continuous + ground_truth and fixed training resets to vary reproducibly.</a:t>
             </a:r>
           </a:p>
         </p:txBody>
@@ -6246,7 +6246,7 @@
                 </a:solidFill>
                 <a:latin typeface="Aptos"/>
               </a:rPr>
-              <a:t>VESSELS SERVED</a:t>
+              <a:t>PORT SERVICE EVENTS</a:t>
             </a:r>
           </a:p>
         </p:txBody>
@@ -6635,7 +6635,7 @@
                 </a:solidFill>
                 <a:latin typeface="Aptos"/>
               </a:rPr>
-              <a:t>BENCHMARK</a:t>
+              <a:t>RUN PLAN</a:t>
             </a:r>
           </a:p>
         </p:txBody>
@@ -6670,7 +6670,7 @@
                 </a:solidFill>
                 <a:latin typeface="Aptos Display"/>
               </a:rPr>
-              <a:t>Continuous task vs. single-mission validation benchmark</a:t>
+              <a:t>Final full-scale run plan</a:t>
             </a:r>
           </a:p>
         </p:txBody>
@@ -6785,7 +6785,7 @@
                 </a:solidFill>
                 <a:latin typeface="Aptos Display"/>
               </a:rPr>
-              <a:t>Continuous + ground truth</a:t>
+              <a:t>Artifact run</a:t>
             </a:r>
           </a:p>
         </p:txBody>
@@ -6865,7 +6865,7 @@
                 </a:solidFill>
                 <a:latin typeface="Aptos"/>
               </a:rPr>
-              <a:t>EVAL TOTAL REWARD</a:t>
+              <a:t>ENVIRONMENT</a:t>
             </a:r>
           </a:p>
         </p:txBody>
@@ -6900,7 +6900,7 @@
                 </a:solidFill>
                 <a:latin typeface="Aptos"/>
               </a:rPr>
-              <a:t>-673.99</a:t>
+              <a:t>Continuous</a:t>
             </a:r>
           </a:p>
         </p:txBody>
@@ -6980,7 +6980,7 @@
                 </a:solidFill>
                 <a:latin typeface="Aptos"/>
               </a:rPr>
-              <a:t>ON-TIME RATE</a:t>
+              <a:t>FORECAST</a:t>
             </a:r>
           </a:p>
         </p:txBody>
@@ -7015,7 +7015,7 @@
                 </a:solidFill>
                 <a:latin typeface="Aptos"/>
               </a:rPr>
-              <a:t>0.759</a:t>
+              <a:t>Ground truth</a:t>
             </a:r>
           </a:p>
         </p:txBody>
@@ -7095,7 +7095,7 @@
                 </a:solidFill>
                 <a:latin typeface="Aptos"/>
               </a:rPr>
-              <a:t>COMPLETED ARRIVALS</a:t>
+              <a:t>ITERATIONS</a:t>
             </a:r>
           </a:p>
         </p:txBody>
@@ -7130,7 +7130,7 @@
                 </a:solidFill>
                 <a:latin typeface="Aptos"/>
               </a:rPr>
-              <a:t>14.8</a:t>
+              <a:t>100</a:t>
             </a:r>
           </a:p>
         </p:txBody>
@@ -7210,7 +7210,7 @@
                 </a:solidFill>
                 <a:latin typeface="Aptos"/>
               </a:rPr>
-              <a:t>VESSELS SERVED</a:t>
+              <a:t>SEED</a:t>
             </a:r>
           </a:p>
         </p:txBody>
@@ -7245,7 +7245,7 @@
                 </a:solidFill>
                 <a:latin typeface="Aptos"/>
               </a:rPr>
-              <a:t>24.2</a:t>
+              <a:t>42</a:t>
             </a:r>
           </a:p>
         </p:txBody>
@@ -7325,7 +7325,7 @@
                 </a:solidFill>
                 <a:latin typeface="Aptos"/>
               </a:rPr>
-              <a:t>MISSION SUCCESS</a:t>
+              <a:t>PURPOSE</a:t>
             </a:r>
           </a:p>
         </p:txBody>
@@ -7360,7 +7360,7 @@
                 </a:solidFill>
                 <a:latin typeface="Aptos"/>
               </a:rPr>
-              <a:t>0.0</a:t>
+              <a:t>Figures, traces, report, and saved model</a:t>
             </a:r>
           </a:p>
         </p:txBody>
@@ -7440,7 +7440,7 @@
                 </a:solidFill>
                 <a:latin typeface="Aptos"/>
               </a:rPr>
-              <a:t>TRACE STEPS</a:t>
+              <a:t>OUTPUTS</a:t>
             </a:r>
           </a:p>
         </p:txBody>
@@ -7475,7 +7475,7 @@
                 </a:solidFill>
                 <a:latin typeface="Aptos"/>
               </a:rPr>
-              <a:t>37</a:t>
+              <a:t>report.md + trace CSVs + plots</a:t>
             </a:r>
           </a:p>
         </p:txBody>
@@ -7555,7 +7555,7 @@
                 </a:solidFill>
                 <a:latin typeface="Aptos Display"/>
               </a:rPr>
-              <a:t>Single mission + ground truth</a:t>
+              <a:t>Multi-seed run</a:t>
             </a:r>
           </a:p>
         </p:txBody>
@@ -7635,7 +7635,7 @@
                 </a:solidFill>
                 <a:latin typeface="Aptos"/>
               </a:rPr>
-              <a:t>EVAL TOTAL REWARD</a:t>
+              <a:t>ENVIRONMENT</a:t>
             </a:r>
           </a:p>
         </p:txBody>
@@ -7666,11 +7666,11 @@
             <a:r>
               <a:rPr sz="1400" b="1">
                 <a:solidFill>
-                  <a:srgbClr val="2B7A78"/>
+                  <a:srgbClr val="14385C"/>
                 </a:solidFill>
                 <a:latin typeface="Aptos"/>
               </a:rPr>
-              <a:t>-481.51</a:t>
+              <a:t>Continuous</a:t>
             </a:r>
           </a:p>
         </p:txBody>
@@ -7750,7 +7750,7 @@
                 </a:solidFill>
                 <a:latin typeface="Aptos"/>
               </a:rPr>
-              <a:t>ON-TIME RATE</a:t>
+              <a:t>FORECAST</a:t>
             </a:r>
           </a:p>
         </p:txBody>
@@ -7785,7 +7785,7 @@
                 </a:solidFill>
                 <a:latin typeface="Aptos"/>
               </a:rPr>
-              <a:t>0.575</a:t>
+              <a:t>Ground truth</a:t>
             </a:r>
           </a:p>
         </p:txBody>
@@ -7865,7 +7865,7 @@
                 </a:solidFill>
                 <a:latin typeface="Aptos"/>
               </a:rPr>
-              <a:t>COMPLETED ARRIVALS</a:t>
+              <a:t>ITERATIONS</a:t>
             </a:r>
           </a:p>
         </p:txBody>
@@ -7900,7 +7900,7 @@
                 </a:solidFill>
                 <a:latin typeface="Aptos"/>
               </a:rPr>
-              <a:t>8.0</a:t>
+              <a:t>100</a:t>
             </a:r>
           </a:p>
         </p:txBody>
@@ -7980,7 +7980,7 @@
                 </a:solidFill>
                 <a:latin typeface="Aptos"/>
               </a:rPr>
-              <a:t>VESSELS SERVED</a:t>
+              <a:t>SEEDS</a:t>
             </a:r>
           </a:p>
         </p:txBody>
@@ -8011,11 +8011,11 @@
             <a:r>
               <a:rPr sz="1400" b="1">
                 <a:solidFill>
-                  <a:srgbClr val="14385C"/>
+                  <a:srgbClr val="2B7A78"/>
                 </a:solidFill>
                 <a:latin typeface="Aptos"/>
               </a:rPr>
-              <a:t>9.4</a:t>
+              <a:t>42, 49, 56, 63, 70</a:t>
             </a:r>
           </a:p>
         </p:txBody>
@@ -8095,7 +8095,7 @@
                 </a:solidFill>
                 <a:latin typeface="Aptos"/>
               </a:rPr>
-              <a:t>MISSION SUCCESS</a:t>
+              <a:t>PURPOSE</a:t>
             </a:r>
           </a:p>
         </p:txBody>
@@ -8126,11 +8126,11 @@
             <a:r>
               <a:rPr sz="1400" b="1">
                 <a:solidFill>
-                  <a:srgbClr val="2B7A78"/>
+                  <a:srgbClr val="14385C"/>
                 </a:solidFill>
                 <a:latin typeface="Aptos"/>
               </a:rPr>
-              <a:t>1.0</a:t>
+              <a:t>Final quantitative stability claim</a:t>
             </a:r>
           </a:p>
         </p:txBody>
@@ -8210,7 +8210,7 @@
                 </a:solidFill>
                 <a:latin typeface="Aptos"/>
               </a:rPr>
-              <a:t>TRACE STEPS</a:t>
+              <a:t>OUTPUTS</a:t>
             </a:r>
           </a:p>
         </p:txBody>
@@ -8245,7 +8245,7 @@
                 </a:solidFill>
                 <a:latin typeface="Aptos"/>
               </a:rPr>
-              <a:t>24</a:t>
+              <a:t>summary.csv + experiment_summary.json</a:t>
             </a:r>
           </a:p>
         </p:txBody>
@@ -8360,7 +8360,7 @@
                 </a:solidFill>
                 <a:latin typeface="Aptos"/>
               </a:rPr>
-              <a:t>The simplified benchmark is easier to complete and gives a cleaner success signal, but the continuous setting still has higher throughput and remains the real target environment.</a:t>
+              <a:t>The project now finishes on one clean task definition: continuous scheduling with reliable forecasts, using one representative artifact run and one five-seed stability run.</a:t>
             </a:r>
           </a:p>
         </p:txBody>
@@ -8614,7 +8614,7 @@
                 </a:solidFill>
                 <a:latin typeface="Aptos Display"/>
               </a:rPr>
-              <a:t>1. Keep v3</a:t>
+              <a:t>1. Run the artifact seed</a:t>
             </a:r>
           </a:p>
         </p:txBody>
@@ -8649,7 +8649,7 @@
                 </a:solidFill>
                 <a:latin typeface="Aptos"/>
               </a:rPr>
-              <a:t>Use transit-rebalanced v3 as the working continuous baseline.</a:t>
+              <a:t>Generate the final figures, traces, report, and saved model from seed 42.</a:t>
             </a:r>
           </a:p>
         </p:txBody>
@@ -8729,7 +8729,7 @@
                 </a:solidFill>
                 <a:latin typeface="Aptos Display"/>
               </a:rPr>
-              <a:t>2. Use the benchmark</a:t>
+              <a:t>2. Run five seeds</a:t>
             </a:r>
           </a:p>
         </p:txBody>
@@ -8764,7 +8764,7 @@
                 </a:solidFill>
                 <a:latin typeface="Aptos"/>
               </a:rPr>
-              <a:t>Use single_mission + ground_truth as the controlled validation benchmark.</a:t>
+              <a:t>Use the same continuous + ground_truth setting for the final stability claim.</a:t>
             </a:r>
           </a:p>
         </p:txBody>
@@ -8844,7 +8844,7 @@
                 </a:solidFill>
                 <a:latin typeface="Aptos Display"/>
               </a:rPr>
-              <a:t>3. Compare across seeds</a:t>
+              <a:t>3. Write the result</a:t>
             </a:r>
           </a:p>
         </p:txBody>
@@ -8879,7 +8879,7 @@
                 </a:solidFill>
                 <a:latin typeface="Aptos"/>
               </a:rPr>
-              <a:t>Run short multi-seed comparisons in both settings.</a:t>
+              <a:t>Use the artifact run for examples and the multi-seed run for the main numbers.</a:t>
             </a:r>
           </a:p>
         </p:txBody>
@@ -8959,7 +8959,7 @@
                 </a:solidFill>
                 <a:latin typeface="Aptos Display"/>
               </a:rPr>
-              <a:t>4. Reintroduce uncertainty</a:t>
+              <a:t>4. Keep scope honest</a:t>
             </a:r>
           </a:p>
         </p:txBody>
@@ -8994,7 +8994,7 @@
                 </a:solidFill>
                 <a:latin typeface="Aptos"/>
               </a:rPr>
-              <a:t>Bring back imperfect forecasting after validating control behavior.</a:t>
+              <a:t>Frame the result as control quality under reliable forecasts.</a:t>
             </a:r>
           </a:p>
         </p:txBody>
@@ -9074,7 +9074,7 @@
                 </a:solidFill>
                 <a:latin typeface="Aptos Display"/>
               </a:rPr>
-              <a:t>5. Decide on realism</a:t>
+              <a:t>5. Future work</a:t>
             </a:r>
           </a:p>
         </p:txBody>
@@ -9109,7 +9109,7 @@
                 </a:solidFill>
                 <a:latin typeface="Aptos"/>
               </a:rPr>
-              <a:t>Then decide whether to move to real ports and nautical distances.</a:t>
+              <a:t>Reintroduce imperfect forecasts and real-port geography afterward.</a:t>
             </a:r>
           </a:p>
         </p:txBody>
@@ -9144,7 +9144,7 @@
                 </a:solidFill>
                 <a:latin typeface="Aptos"/>
               </a:rPr>
-              <a:t>The short-term goal is not to replace the continuous environment, but to validate the control logic under cleaner conditions.</a:t>
+              <a:t>This finish line is intentionally narrow: complete the project cleanly on the continuous environment, then expand realism afterward.</a:t>
             </a:r>
           </a:p>
         </p:txBody>
@@ -14844,7 +14844,7 @@
                 </a:solidFill>
                 <a:latin typeface="Aptos Display"/>
               </a:rPr>
-              <a:t>Controlled validation benchmark</a:t>
+              <a:t>Final completion path</a:t>
             </a:r>
           </a:p>
         </p:txBody>
@@ -14883,7 +14883,7 @@
                 </a:solidFill>
                 <a:latin typeface="Aptos"/>
               </a:rPr>
-              <a:t>single_mission episodes</a:t>
+              <a:t>continuous episodes</a:t>
             </a:r>
           </a:p>
           <a:p>
@@ -14915,7 +14915,7 @@
                 </a:solidFill>
                 <a:latin typeface="Aptos"/>
               </a:rPr>
-              <a:t>Each vessel completes at most one trip per episode</a:t>
+              <a:t>one artifact run plus one five-seed run</a:t>
             </a:r>
           </a:p>
           <a:p>
@@ -14931,7 +14931,7 @@
                 </a:solidFill>
                 <a:latin typeface="Aptos"/>
               </a:rPr>
-              <a:t>Used to validate control logic before reintroducing forecast error</a:t>
+              <a:t>designed to isolate control quality while finishing the project</a:t>
             </a:r>
           </a:p>
         </p:txBody>
@@ -15082,7 +15082,7 @@
                 </a:solidFill>
                 <a:latin typeface="Aptos"/>
               </a:rPr>
-              <a:t>Vessels served</a:t>
+              <a:t>Port service events</a:t>
             </a:r>
           </a:p>
           <a:p>

</xml_diff>